<commit_message>
Update PINN and DeepXDE slides
</commit_message>
<xml_diff>
--- a/20260319_AI4S_PINN/lecture_DeepXDE_PINN.pptx
+++ b/20260319_AI4S_PINN/lecture_DeepXDE_PINN.pptx
@@ -6196,7 +6196,7 @@
         <p:spPr>
           <a:xfrm>
             <a:off x="3111769" y="3737471"/>
-            <a:ext cx="5968302" cy="1569660"/>
+            <a:ext cx="5968301" cy="2308324"/>
           </a:xfrm>
           <a:prstGeom prst="rect">
             <a:avLst/>
@@ -6273,6 +6273,9 @@
               </a:rPr>
               <a:t>Yale University</a:t>
             </a:r>
+          </a:p>
+          <a:p>
+            <a:pPr algn="ctr"/>
             <a:endParaRPr lang="en-US" altLang="zh-CN" sz="2400" dirty="0">
               <a:solidFill>
                 <a:prstClr val="black"/>
@@ -6281,6 +6284,20 @@
               <a:ea typeface="宋体" panose="02010600030101010101" pitchFamily="2" charset="-122"/>
               <a:cs typeface="Arial" panose="020B0604020202020204" pitchFamily="34" charset="0"/>
             </a:endParaRPr>
+          </a:p>
+          <a:p>
+            <a:pPr algn="ctr"/>
+            <a:r>
+              <a:rPr lang="en-US" altLang="zh-CN" sz="2400" dirty="0">
+                <a:solidFill>
+                  <a:prstClr val="black"/>
+                </a:solidFill>
+                <a:latin typeface="Arial" panose="020B0604020202020204" pitchFamily="34" charset="0"/>
+                <a:ea typeface="宋体" panose="02010600030101010101" pitchFamily="2" charset="-122"/>
+                <a:cs typeface="Arial" panose="020B0604020202020204" pitchFamily="34" charset="0"/>
+              </a:rPr>
+              <a:t>Mar. 19, 2026</a:t>
+            </a:r>
           </a:p>
         </p:txBody>
       </p:sp>

</xml_diff>